<commit_message>
iChange default port for OMAG Server Platform to 7443
Signed-off-by: Mandy Chessell <mandy.e.chessell@gmail.com>
</commit_message>
<xml_diff>
--- a/site/docs/practices/perspectives/Data Governance Perspectives Icons.pptx
+++ b/site/docs/practices/perspectives/Data Governance Perspectives Icons.pptx
@@ -9905,14 +9905,14 @@
           <a:p>
             <a:pPr algn="ctr" eaLnBrk="1" hangingPunct="1"/>
             <a:r>
-              <a:rPr lang="en-GB" altLang="en-US" sz="1400"/>
+              <a:rPr lang="en-GB" altLang="en-US" sz="1400" dirty="0"/>
               <a:t>Incident</a:t>
             </a:r>
           </a:p>
           <a:p>
             <a:pPr algn="ctr" eaLnBrk="1" hangingPunct="1"/>
             <a:r>
-              <a:rPr lang="en-GB" altLang="en-US" sz="1400"/>
+              <a:rPr lang="en-GB" altLang="en-US" sz="1400" dirty="0"/>
               <a:t>Owner</a:t>
             </a:r>
           </a:p>
@@ -15308,7 +15308,13 @@
           <a:p>
             <a:r>
               <a:rPr lang="en-US" dirty="0"/>
-              <a:t>Role include responsibilities and a scope.</a:t>
+              <a:t>Role includes responsibilities and a scope.</a:t>
+            </a:r>
+          </a:p>
+          <a:p>
+            <a:r>
+              <a:rPr lang="en-US" dirty="0"/>
+              <a:t>It is a specific “slot” in the organization</a:t>
             </a:r>
           </a:p>
         </p:txBody>

</xml_diff>